<commit_message>
Pełne polskie tłumaczenie witryny AU (Dostępny Uniwersytet)
Przetłumaczono strony HTML, napisy VTT, komunikaty skryptów oraz dokumenty
Word/PowerPoint/PDF. Celowe błędy dostępności w wersji Before/Przed zachowane
(demonstracja); przetłumaczono jedynie treść. Dostępny PDF wygenerowany na nowo
(tagged, PDF/UA-1 compliant wg veraPDF). Sekcje obcojęzyczne (es/fr) zachowane.

Oryginał: University of Washington (AccessComputing), licencja CC BY-NC-SA 4.0.
</commit_message>
<xml_diff>
--- a/documents/presentation_NOTaccessible.pptx
+++ b/documents/presentation_NOTaccessible.pptx
@@ -7123,7 +7123,7 @@
               <a:rPr lang="en-US" sz="7200" dirty="0">
                 <a:latin typeface="+mj-lt"/>
               </a:rPr>
-              <a:t>Introduction to Physics</a:t>
+              <a:t>Wprowadzenie do fizyki</a:t>
             </a:r>
           </a:p>
         </p:txBody>
@@ -7223,7 +7223,7 @@
               <a:rPr lang="en-US" sz="6000" dirty="0">
                 <a:latin typeface="+mj-lt"/>
               </a:rPr>
-              <a:t>Textbook</a:t>
+              <a:t>Podręcznik</a:t>
             </a:r>
           </a:p>
         </p:txBody>
@@ -7260,7 +7260,7 @@
               <a:rPr lang="en-US" dirty="0">
                 <a:latin typeface="+mn-lt"/>
               </a:rPr>
-              <a:t>Text Introduction to Physics, Second Edition, authored by the instructor</a:t>
+              <a:t>Tekst Wprowadzenie do fizyki, wydanie drugie, autorstwa prowadzącego</a:t>
             </a:r>
           </a:p>
           <a:p>
@@ -7431,7 +7431,7 @@
               <a:rPr lang="en-US" dirty="0">
                 <a:latin typeface="+mn-lt"/>
               </a:rPr>
-              <a:t>To offer students exposure to basic principles of Physics</a:t>
+              <a:t>Zapoznanie studentów z podstawowymi zasadami fizyki</a:t>
             </a:r>
           </a:p>
           <a:p>
@@ -7444,7 +7444,7 @@
               <a:rPr lang="en-US" dirty="0">
                 <a:latin typeface="+mn-lt"/>
               </a:rPr>
-              <a:t>To provide students with rich, thought-provoking discussions during lecture sessions</a:t>
+              <a:t>Zapewnienie studentom bogatych, skłaniających do myślenia dyskusji podczas wykładów</a:t>
             </a:r>
           </a:p>
           <a:p>
@@ -7457,7 +7457,7 @@
               <a:rPr lang="en-US" dirty="0">
                 <a:latin typeface="+mn-lt"/>
               </a:rPr>
-              <a:t>To provide students with experiential learning opportunities during laboratory sessions</a:t>
+              <a:t>Zapewnienie studentom możliwości uczenia się przez doświadczenie podczas zajęć laboratoryjnych</a:t>
             </a:r>
           </a:p>
         </p:txBody>
@@ -7489,7 +7489,7 @@
               <a:rPr lang="en-US" sz="6000" dirty="0">
                 <a:latin typeface="+mj-lt"/>
               </a:rPr>
-              <a:t>Course Objectives</a:t>
+              <a:t>Cele kursu</a:t>
             </a:r>
           </a:p>
         </p:txBody>
@@ -7670,7 +7670,7 @@
               <a:rPr lang="en-US" sz="6000" dirty="0">
                 <a:latin typeface="+mj-lt"/>
               </a:rPr>
-              <a:t>Class Schedule</a:t>
+              <a:t>Harmonogram zajęć</a:t>
             </a:r>
           </a:p>
         </p:txBody>
@@ -7710,7 +7710,7 @@
       </p:sp>
       <p:graphicFrame>
         <p:nvGraphicFramePr>
-          <p:cNvPr id="9" name="Table 8" descr="Simple table with 3 columns and 7 rows.">
+          <p:cNvPr id="9" name="Table 8" descr="Prosta tabela z 3 kolumnami i 7 wierszami.">
             <a:extLst>
               <a:ext uri="{FF2B5EF4-FFF2-40B4-BE49-F238E27FC236}">
                 <a16:creationId xmlns:a16="http://schemas.microsoft.com/office/drawing/2014/main" id="{5D8A8DE4-196E-1F44-8828-2FD048152710}"/>
@@ -7779,7 +7779,7 @@
                         <a:rPr lang="en-US" sz="2400" dirty="0">
                           <a:effectLst/>
                         </a:rPr>
-                        <a:t>Week</a:t>
+                        <a:t>Tydzień</a:t>
                       </a:r>
                       <a:endParaRPr lang="en-US" sz="2400" dirty="0">
                         <a:effectLst/>
@@ -7808,7 +7808,7 @@
                         <a:rPr lang="en-US" sz="2400" dirty="0">
                           <a:effectLst/>
                         </a:rPr>
-                        <a:t>Topic</a:t>
+                        <a:t>Temat</a:t>
                       </a:r>
                       <a:endParaRPr lang="en-US" sz="2400" dirty="0">
                         <a:effectLst/>
@@ -7837,7 +7837,7 @@
                         <a:rPr lang="en-US" sz="2400" dirty="0">
                           <a:effectLst/>
                         </a:rPr>
-                        <a:t>Reading Assignment</a:t>
+                        <a:t>Zadana lektura</a:t>
                       </a:r>
                       <a:endParaRPr lang="en-US" sz="2400" dirty="0">
                         <a:effectLst/>
@@ -7902,7 +7902,7 @@
                         <a:rPr lang="en-US" sz="2400" dirty="0">
                           <a:effectLst/>
                         </a:rPr>
-                        <a:t>Course Introduction</a:t>
+                        <a:t>Wprowadzenie do kursu</a:t>
                       </a:r>
                       <a:endParaRPr lang="en-US" sz="2400" dirty="0">
                         <a:effectLst/>
@@ -7931,7 +7931,7 @@
                         <a:rPr lang="en-US" sz="2400">
                           <a:effectLst/>
                         </a:rPr>
-                        <a:t>Chapter 1</a:t>
+                        <a:t>Rozdział 1</a:t>
                       </a:r>
                       <a:endParaRPr lang="en-US" sz="2400">
                         <a:effectLst/>
@@ -7996,7 +7996,7 @@
                         <a:rPr lang="en-US" sz="2400" dirty="0">
                           <a:effectLst/>
                         </a:rPr>
-                        <a:t>Inertia, equilibrium, kinematics</a:t>
+                        <a:t>Bezwładność, równowaga, kinematyka</a:t>
                       </a:r>
                       <a:endParaRPr lang="en-US" sz="2400" dirty="0">
                         <a:effectLst/>
@@ -8025,7 +8025,7 @@
                         <a:rPr lang="en-US" sz="2400" dirty="0">
                           <a:effectLst/>
                         </a:rPr>
-                        <a:t>Chapters 2-3</a:t>
+                        <a:t>Rozdziały 2-3</a:t>
                       </a:r>
                       <a:endParaRPr lang="en-US" sz="2400" dirty="0">
                         <a:effectLst/>
@@ -8090,7 +8090,7 @@
                         <a:rPr lang="en-US" sz="2400" dirty="0">
                           <a:effectLst/>
                         </a:rPr>
-                        <a:t>Newton’s laws, vectors, momentum, energy</a:t>
+                        <a:t>Zasady dynamiki Newtona, wektory, pęd, energia</a:t>
                       </a:r>
                       <a:endParaRPr lang="en-US" sz="2400" dirty="0">
                         <a:effectLst/>
@@ -8119,7 +8119,7 @@
                         <a:rPr lang="en-US" sz="2400" dirty="0">
                           <a:effectLst/>
                         </a:rPr>
-                        <a:t>Chapters 4-7</a:t>
+                        <a:t>Rozdziały 4-7</a:t>
                       </a:r>
                       <a:endParaRPr lang="en-US" sz="2400" dirty="0">
                         <a:effectLst/>
@@ -8184,7 +8184,7 @@
                         <a:rPr lang="en-US" sz="2400">
                           <a:effectLst/>
                         </a:rPr>
-                        <a:t>Matter, elasticity, scaling</a:t>
+                        <a:t>Materia, sprężystość, skalowanie</a:t>
                       </a:r>
                       <a:endParaRPr lang="en-US" sz="2400">
                         <a:effectLst/>
@@ -8213,7 +8213,7 @@
                         <a:rPr lang="en-US" sz="2400" dirty="0">
                           <a:effectLst/>
                         </a:rPr>
-                        <a:t>Chapters 8-10</a:t>
+                        <a:t>Rozdziały 8-10</a:t>
                       </a:r>
                       <a:endParaRPr lang="en-US" sz="2400" dirty="0">
                         <a:effectLst/>
@@ -8278,7 +8278,7 @@
                         <a:rPr lang="en-US" sz="2400" dirty="0">
                           <a:effectLst/>
                         </a:rPr>
-                        <a:t>Wake kinematics, sound, electricity, magnetism, induction</a:t>
+                        <a:t>Kinematyka fal, dźwięk, elektryczność, magnetyzm, indukcja</a:t>
                       </a:r>
                       <a:endParaRPr lang="en-US" sz="2400" dirty="0">
                         <a:effectLst/>
@@ -8307,7 +8307,7 @@
                         <a:rPr lang="en-US" sz="2400" dirty="0">
                           <a:effectLst/>
                         </a:rPr>
-                        <a:t>Chapters 11-15</a:t>
+                        <a:t>Rozdziały 11-15</a:t>
                       </a:r>
                       <a:endParaRPr lang="en-US" sz="2400" dirty="0">
                         <a:effectLst/>
@@ -8372,7 +8372,7 @@
                         <a:rPr lang="en-US" sz="2400">
                           <a:effectLst/>
                         </a:rPr>
-                        <a:t>Light, reflection and refraction, emission</a:t>
+                        <a:t>Światło, odbicie i załamanie, emisja</a:t>
                       </a:r>
                       <a:endParaRPr lang="en-US" sz="2400">
                         <a:effectLst/>
@@ -8401,7 +8401,7 @@
                         <a:rPr lang="en-US" sz="2400" dirty="0">
                           <a:effectLst/>
                         </a:rPr>
-                        <a:t>Chapters 16-18</a:t>
+                        <a:t>Rozdziały 16-18</a:t>
                       </a:r>
                       <a:endParaRPr lang="en-US" sz="2400" dirty="0">
                         <a:effectLst/>
@@ -8466,7 +8466,7 @@
                         <a:rPr lang="en-US" sz="2400" dirty="0">
                           <a:effectLst/>
                         </a:rPr>
-                        <a:t>Review, final exam</a:t>
+                        <a:t>Powtórzenie, egzamin końcowy</a:t>
                       </a:r>
                       <a:endParaRPr lang="en-US" sz="2400" dirty="0">
                         <a:effectLst/>
@@ -8574,7 +8574,7 @@
               <a:rPr lang="en-US" sz="6000" dirty="0">
                 <a:latin typeface="+mj-lt"/>
               </a:rPr>
-              <a:t>Grades</a:t>
+              <a:t>Oceny</a:t>
             </a:r>
           </a:p>
         </p:txBody>
@@ -8616,14 +8616,14 @@
               <a:rPr lang="en-US" dirty="0">
                 <a:latin typeface="+mn-lt"/>
               </a:rPr>
-              <a:t>Grades will be assigned on a ten-point scale (90 to 100 is an A, 80 to 89 is a B, etc.). Homework, exams, and projects will be weighted as follows:</a:t>
+              <a:t>Oceny będą przyznawane w skali dziesięciopunktowej (90 do 100 to 5, 80 do 89 to 4 itd.). Prace domowe, egzaminy i projekty będą ważone następująco:</a:t>
             </a:r>
           </a:p>
         </p:txBody>
       </p:sp>
       <p:graphicFrame>
         <p:nvGraphicFramePr>
-          <p:cNvPr id="15" name="Diagram 14" descr="Grading rubric">
+          <p:cNvPr id="15" name="Diagram 14" descr="Kryteria oceniania">
             <a:extLst>
               <a:ext uri="{FF2B5EF4-FFF2-40B4-BE49-F238E27FC236}">
                 <a16:creationId xmlns:a16="http://schemas.microsoft.com/office/drawing/2014/main" id="{1507DBC3-0BD6-7D2A-FC01-6DA1A453CC38}"/>

</xml_diff>